<commit_message>
Deploying to gh-pages from @ wengzf20/wengzf20.github.io@f6066a653eec7cbef12101ffa607ae4145f12c49 🚀
</commit_message>
<xml_diff>
--- a/assets/img/publication_preview/template.pptx
+++ b/assets/img/publication_preview/template.pptx
@@ -243,7 +243,7 @@
           <a:p>
             <a:fld id="{5AA09F1C-FA1A-5B4D-A72E-9DB711FD4947}" type="datetimeFigureOut">
               <a:rPr lang="en-US" smtClean="0"/>
-              <a:t>9/23/24</a:t>
+              <a:t>3/19/25</a:t>
             </a:fld>
             <a:endParaRPr lang="en-US"/>
           </a:p>
@@ -413,7 +413,7 @@
           <a:p>
             <a:fld id="{5AA09F1C-FA1A-5B4D-A72E-9DB711FD4947}" type="datetimeFigureOut">
               <a:rPr lang="en-US" smtClean="0"/>
-              <a:t>9/23/24</a:t>
+              <a:t>3/19/25</a:t>
             </a:fld>
             <a:endParaRPr lang="en-US"/>
           </a:p>
@@ -593,7 +593,7 @@
           <a:p>
             <a:fld id="{5AA09F1C-FA1A-5B4D-A72E-9DB711FD4947}" type="datetimeFigureOut">
               <a:rPr lang="en-US" smtClean="0"/>
-              <a:t>9/23/24</a:t>
+              <a:t>3/19/25</a:t>
             </a:fld>
             <a:endParaRPr lang="en-US"/>
           </a:p>
@@ -763,7 +763,7 @@
           <a:p>
             <a:fld id="{5AA09F1C-FA1A-5B4D-A72E-9DB711FD4947}" type="datetimeFigureOut">
               <a:rPr lang="en-US" smtClean="0"/>
-              <a:t>9/23/24</a:t>
+              <a:t>3/19/25</a:t>
             </a:fld>
             <a:endParaRPr lang="en-US"/>
           </a:p>
@@ -1007,7 +1007,7 @@
           <a:p>
             <a:fld id="{5AA09F1C-FA1A-5B4D-A72E-9DB711FD4947}" type="datetimeFigureOut">
               <a:rPr lang="en-US" smtClean="0"/>
-              <a:t>9/23/24</a:t>
+              <a:t>3/19/25</a:t>
             </a:fld>
             <a:endParaRPr lang="en-US"/>
           </a:p>
@@ -1239,7 +1239,7 @@
           <a:p>
             <a:fld id="{5AA09F1C-FA1A-5B4D-A72E-9DB711FD4947}" type="datetimeFigureOut">
               <a:rPr lang="en-US" smtClean="0"/>
-              <a:t>9/23/24</a:t>
+              <a:t>3/19/25</a:t>
             </a:fld>
             <a:endParaRPr lang="en-US"/>
           </a:p>
@@ -1606,7 +1606,7 @@
           <a:p>
             <a:fld id="{5AA09F1C-FA1A-5B4D-A72E-9DB711FD4947}" type="datetimeFigureOut">
               <a:rPr lang="en-US" smtClean="0"/>
-              <a:t>9/23/24</a:t>
+              <a:t>3/19/25</a:t>
             </a:fld>
             <a:endParaRPr lang="en-US"/>
           </a:p>
@@ -1724,7 +1724,7 @@
           <a:p>
             <a:fld id="{5AA09F1C-FA1A-5B4D-A72E-9DB711FD4947}" type="datetimeFigureOut">
               <a:rPr lang="en-US" smtClean="0"/>
-              <a:t>9/23/24</a:t>
+              <a:t>3/19/25</a:t>
             </a:fld>
             <a:endParaRPr lang="en-US"/>
           </a:p>
@@ -1819,7 +1819,7 @@
           <a:p>
             <a:fld id="{5AA09F1C-FA1A-5B4D-A72E-9DB711FD4947}" type="datetimeFigureOut">
               <a:rPr lang="en-US" smtClean="0"/>
-              <a:t>9/23/24</a:t>
+              <a:t>3/19/25</a:t>
             </a:fld>
             <a:endParaRPr lang="en-US"/>
           </a:p>
@@ -2096,7 +2096,7 @@
           <a:p>
             <a:fld id="{5AA09F1C-FA1A-5B4D-A72E-9DB711FD4947}" type="datetimeFigureOut">
               <a:rPr lang="en-US" smtClean="0"/>
-              <a:t>9/23/24</a:t>
+              <a:t>3/19/25</a:t>
             </a:fld>
             <a:endParaRPr lang="en-US"/>
           </a:p>
@@ -2353,7 +2353,7 @@
           <a:p>
             <a:fld id="{5AA09F1C-FA1A-5B4D-A72E-9DB711FD4947}" type="datetimeFigureOut">
               <a:rPr lang="en-US" smtClean="0"/>
-              <a:t>9/23/24</a:t>
+              <a:t>3/19/25</a:t>
             </a:fld>
             <a:endParaRPr lang="en-US"/>
           </a:p>
@@ -2566,7 +2566,7 @@
           <a:p>
             <a:fld id="{5AA09F1C-FA1A-5B4D-A72E-9DB711FD4947}" type="datetimeFigureOut">
               <a:rPr lang="en-US" smtClean="0"/>
-              <a:t>9/23/24</a:t>
+              <a:t>3/19/25</a:t>
             </a:fld>
             <a:endParaRPr lang="en-US"/>
           </a:p>
@@ -2973,10 +2973,10 @@
       </p:grpSpPr>
       <p:pic>
         <p:nvPicPr>
-          <p:cNvPr id="3" name="Picture 2">
+          <p:cNvPr id="4" name="Picture 3">
             <a:extLst>
               <a:ext uri="{FF2B5EF4-FFF2-40B4-BE49-F238E27FC236}">
-                <a16:creationId xmlns:a16="http://schemas.microsoft.com/office/drawing/2014/main" id="{7A146F9B-B864-3643-B842-E7CEBB229FA8}"/>
+                <a16:creationId xmlns:a16="http://schemas.microsoft.com/office/drawing/2014/main" id="{F112C24C-47D1-1D4A-875E-E811CF2532EE}"/>
               </a:ext>
             </a:extLst>
           </p:cNvPr>
@@ -2985,15 +2985,16 @@
           </p:cNvPicPr>
           <p:nvPr/>
         </p:nvPicPr>
-        <p:blipFill rotWithShape="1">
+        <p:blipFill>
           <a:blip r:embed="rId2"/>
-          <a:srcRect l="5534" r="16205" b="15012"/>
-          <a:stretch/>
+          <a:stretch>
+            <a:fillRect/>
+          </a:stretch>
         </p:blipFill>
         <p:spPr>
           <a:xfrm>
-            <a:off x="468" y="450330"/>
-            <a:ext cx="3605524" cy="2780549"/>
+            <a:off x="-5922" y="494760"/>
+            <a:ext cx="3612294" cy="2599427"/>
           </a:xfrm>
           <a:prstGeom prst="rect">
             <a:avLst/>

</xml_diff>

<commit_message>
Deploying to gh-pages from @ wengzf20/wengzf20.github.io@2509033da57106e9a5e5cda1691e186f8daea9a7 🚀
</commit_message>
<xml_diff>
--- a/assets/img/publication_preview/template.pptx
+++ b/assets/img/publication_preview/template.pptx
@@ -243,7 +243,7 @@
           <a:p>
             <a:fld id="{5AA09F1C-FA1A-5B4D-A72E-9DB711FD4947}" type="datetimeFigureOut">
               <a:rPr lang="en-US" smtClean="0"/>
-              <a:t>3/19/25</a:t>
+              <a:t>9/18/25</a:t>
             </a:fld>
             <a:endParaRPr lang="en-US"/>
           </a:p>
@@ -413,7 +413,7 @@
           <a:p>
             <a:fld id="{5AA09F1C-FA1A-5B4D-A72E-9DB711FD4947}" type="datetimeFigureOut">
               <a:rPr lang="en-US" smtClean="0"/>
-              <a:t>3/19/25</a:t>
+              <a:t>9/18/25</a:t>
             </a:fld>
             <a:endParaRPr lang="en-US"/>
           </a:p>
@@ -593,7 +593,7 @@
           <a:p>
             <a:fld id="{5AA09F1C-FA1A-5B4D-A72E-9DB711FD4947}" type="datetimeFigureOut">
               <a:rPr lang="en-US" smtClean="0"/>
-              <a:t>3/19/25</a:t>
+              <a:t>9/18/25</a:t>
             </a:fld>
             <a:endParaRPr lang="en-US"/>
           </a:p>
@@ -763,7 +763,7 @@
           <a:p>
             <a:fld id="{5AA09F1C-FA1A-5B4D-A72E-9DB711FD4947}" type="datetimeFigureOut">
               <a:rPr lang="en-US" smtClean="0"/>
-              <a:t>3/19/25</a:t>
+              <a:t>9/18/25</a:t>
             </a:fld>
             <a:endParaRPr lang="en-US"/>
           </a:p>
@@ -1007,7 +1007,7 @@
           <a:p>
             <a:fld id="{5AA09F1C-FA1A-5B4D-A72E-9DB711FD4947}" type="datetimeFigureOut">
               <a:rPr lang="en-US" smtClean="0"/>
-              <a:t>3/19/25</a:t>
+              <a:t>9/18/25</a:t>
             </a:fld>
             <a:endParaRPr lang="en-US"/>
           </a:p>
@@ -1239,7 +1239,7 @@
           <a:p>
             <a:fld id="{5AA09F1C-FA1A-5B4D-A72E-9DB711FD4947}" type="datetimeFigureOut">
               <a:rPr lang="en-US" smtClean="0"/>
-              <a:t>3/19/25</a:t>
+              <a:t>9/18/25</a:t>
             </a:fld>
             <a:endParaRPr lang="en-US"/>
           </a:p>
@@ -1606,7 +1606,7 @@
           <a:p>
             <a:fld id="{5AA09F1C-FA1A-5B4D-A72E-9DB711FD4947}" type="datetimeFigureOut">
               <a:rPr lang="en-US" smtClean="0"/>
-              <a:t>3/19/25</a:t>
+              <a:t>9/18/25</a:t>
             </a:fld>
             <a:endParaRPr lang="en-US"/>
           </a:p>
@@ -1724,7 +1724,7 @@
           <a:p>
             <a:fld id="{5AA09F1C-FA1A-5B4D-A72E-9DB711FD4947}" type="datetimeFigureOut">
               <a:rPr lang="en-US" smtClean="0"/>
-              <a:t>3/19/25</a:t>
+              <a:t>9/18/25</a:t>
             </a:fld>
             <a:endParaRPr lang="en-US"/>
           </a:p>
@@ -1819,7 +1819,7 @@
           <a:p>
             <a:fld id="{5AA09F1C-FA1A-5B4D-A72E-9DB711FD4947}" type="datetimeFigureOut">
               <a:rPr lang="en-US" smtClean="0"/>
-              <a:t>3/19/25</a:t>
+              <a:t>9/18/25</a:t>
             </a:fld>
             <a:endParaRPr lang="en-US"/>
           </a:p>
@@ -2096,7 +2096,7 @@
           <a:p>
             <a:fld id="{5AA09F1C-FA1A-5B4D-A72E-9DB711FD4947}" type="datetimeFigureOut">
               <a:rPr lang="en-US" smtClean="0"/>
-              <a:t>3/19/25</a:t>
+              <a:t>9/18/25</a:t>
             </a:fld>
             <a:endParaRPr lang="en-US"/>
           </a:p>
@@ -2353,7 +2353,7 @@
           <a:p>
             <a:fld id="{5AA09F1C-FA1A-5B4D-A72E-9DB711FD4947}" type="datetimeFigureOut">
               <a:rPr lang="en-US" smtClean="0"/>
-              <a:t>3/19/25</a:t>
+              <a:t>9/18/25</a:t>
             </a:fld>
             <a:endParaRPr lang="en-US"/>
           </a:p>
@@ -2566,7 +2566,7 @@
           <a:p>
             <a:fld id="{5AA09F1C-FA1A-5B4D-A72E-9DB711FD4947}" type="datetimeFigureOut">
               <a:rPr lang="en-US" smtClean="0"/>
-              <a:t>3/19/25</a:t>
+              <a:t>9/18/25</a:t>
             </a:fld>
             <a:endParaRPr lang="en-US"/>
           </a:p>
@@ -2973,10 +2973,10 @@
       </p:grpSpPr>
       <p:pic>
         <p:nvPicPr>
-          <p:cNvPr id="4" name="Picture 3">
+          <p:cNvPr id="2" name="Picture 1">
             <a:extLst>
               <a:ext uri="{FF2B5EF4-FFF2-40B4-BE49-F238E27FC236}">
-                <a16:creationId xmlns:a16="http://schemas.microsoft.com/office/drawing/2014/main" id="{F112C24C-47D1-1D4A-875E-E811CF2532EE}"/>
+                <a16:creationId xmlns:a16="http://schemas.microsoft.com/office/drawing/2014/main" id="{A383E4EB-F80B-CC42-9730-C14124362BF8}"/>
               </a:ext>
             </a:extLst>
           </p:cNvPr>
@@ -2993,8 +2993,8 @@
         </p:blipFill>
         <p:spPr>
           <a:xfrm>
-            <a:off x="-5922" y="494760"/>
-            <a:ext cx="3612294" cy="2599427"/>
+            <a:off x="187325" y="657225"/>
+            <a:ext cx="3225800" cy="2286000"/>
           </a:xfrm>
           <a:prstGeom prst="rect">
             <a:avLst/>

</xml_diff>